<commit_message>
feat: implement vendor document generation scripts and initialize procurement dashboard UI
</commit_message>
<xml_diff>
--- a/Vendor documents/Global_Marketing_Deck.pptx
+++ b/Vendor documents/Global_Marketing_Deck.pptx
@@ -13,39 +13,6 @@
     <p:sldId id="261" r:id="rId12"/>
     <p:sldId id="262" r:id="rId13"/>
     <p:sldId id="263" r:id="rId14"/>
-    <p:sldId id="264" r:id="rId15"/>
-    <p:sldId id="265" r:id="rId16"/>
-    <p:sldId id="266" r:id="rId17"/>
-    <p:sldId id="267" r:id="rId18"/>
-    <p:sldId id="268" r:id="rId19"/>
-    <p:sldId id="269" r:id="rId20"/>
-    <p:sldId id="270" r:id="rId21"/>
-    <p:sldId id="271" r:id="rId22"/>
-    <p:sldId id="272" r:id="rId23"/>
-    <p:sldId id="273" r:id="rId24"/>
-    <p:sldId id="274" r:id="rId25"/>
-    <p:sldId id="275" r:id="rId26"/>
-    <p:sldId id="276" r:id="rId27"/>
-    <p:sldId id="277" r:id="rId28"/>
-    <p:sldId id="278" r:id="rId29"/>
-    <p:sldId id="279" r:id="rId30"/>
-    <p:sldId id="280" r:id="rId31"/>
-    <p:sldId id="281" r:id="rId32"/>
-    <p:sldId id="282" r:id="rId33"/>
-    <p:sldId id="283" r:id="rId34"/>
-    <p:sldId id="284" r:id="rId35"/>
-    <p:sldId id="285" r:id="rId36"/>
-    <p:sldId id="286" r:id="rId37"/>
-    <p:sldId id="287" r:id="rId38"/>
-    <p:sldId id="288" r:id="rId39"/>
-    <p:sldId id="289" r:id="rId40"/>
-    <p:sldId id="290" r:id="rId41"/>
-    <p:sldId id="291" r:id="rId42"/>
-    <p:sldId id="292" r:id="rId43"/>
-    <p:sldId id="293" r:id="rId44"/>
-    <p:sldId id="294" r:id="rId45"/>
-    <p:sldId id="295" r:id="rId46"/>
-    <p:sldId id="296" r:id="rId47"/>
   </p:sldIdLst>
   <p:sldSz cx="9144000" cy="6858000" type="screen4x3"/>
   <p:notesSz cx="6858000" cy="9144000"/>
@@ -3144,7 +3111,7 @@
           <a:lstStyle/>
           <a:p>
             <a:r>
-              <a:t>Global Media Hub Strategy Deck</a:t>
+              <a:t>Global Media Hub Strategic Mapping</a:t>
             </a:r>
           </a:p>
         </p:txBody>
@@ -3165,623 +3132,7 @@
           <a:lstStyle/>
           <a:p>
             <a:r>
-              <a:t>Confidential Proposal - EFFICIENT, GLOBAL-SCALE, INTEGRATED</a:t>
-            </a:r>
-          </a:p>
-        </p:txBody>
-      </p:sp>
-    </p:spTree>
-  </p:cSld>
-  <p:clrMapOvr>
-    <a:masterClrMapping/>
-  </p:clrMapOvr>
-</p:sld>
-</file>
-
-<file path=ppt/slides/slide10.xml><?xml version="1.0" encoding="utf-8"?>
-<p:sld xmlns:a="http://schemas.openxmlformats.org/drawingml/2006/main" xmlns:p="http://schemas.openxmlformats.org/presentationml/2006/main" xmlns:r="http://schemas.openxmlformats.org/officeDocument/2006/relationships">
-  <p:cSld>
-    <p:spTree>
-      <p:nvGrpSpPr>
-        <p:cNvPr id="1" name=""/>
-        <p:cNvGrpSpPr/>
-        <p:nvPr/>
-      </p:nvGrpSpPr>
-      <p:grpSpPr/>
-      <p:sp>
-        <p:nvSpPr>
-          <p:cNvPr id="2" name="Title 1"/>
-          <p:cNvSpPr>
-            <a:spLocks noGrp="1"/>
-          </p:cNvSpPr>
-          <p:nvPr>
-            <p:ph type="title"/>
-          </p:nvPr>
-        </p:nvSpPr>
-        <p:spPr/>
-        <p:txBody>
-          <a:bodyPr/>
-          <a:lstStyle/>
-          <a:p>
-            <a:r>
-              <a:t>Slide 9: paradigm-shifting ROI</a:t>
-            </a:r>
-          </a:p>
-        </p:txBody>
-      </p:sp>
-      <p:sp>
-        <p:nvSpPr>
-          <p:cNvPr id="3" name="Content Placeholder 2"/>
-          <p:cNvSpPr>
-            <a:spLocks noGrp="1"/>
-          </p:cNvSpPr>
-          <p:nvPr>
-            <p:ph idx="1"/>
-          </p:nvPr>
-        </p:nvSpPr>
-        <p:spPr/>
-        <p:txBody>
-          <a:bodyPr/>
-          <a:lstStyle/>
-          <a:p>
-            <a:r>
-              <a:t>Regarding the strategy, we believe that quantum-leap brand awareness is the key to unlocking market share in SEA. Our team will deploy growth-hacking strategy to maximize reach.</a:t>
-            </a:r>
-          </a:p>
-          <a:p>
-            <a:pPr>
-              <a:defRPr b="1"/>
-            </a:pPr>
-            <a:r>
-              <a:t>PROPOSED INVESTMENT for Strategy: $80,000 (Ref: SOW-X-8)</a:t>
-            </a:r>
-          </a:p>
-        </p:txBody>
-      </p:sp>
-    </p:spTree>
-  </p:cSld>
-  <p:clrMapOvr>
-    <a:masterClrMapping/>
-  </p:clrMapOvr>
-</p:sld>
-</file>
-
-<file path=ppt/slides/slide11.xml><?xml version="1.0" encoding="utf-8"?>
-<p:sld xmlns:a="http://schemas.openxmlformats.org/drawingml/2006/main" xmlns:p="http://schemas.openxmlformats.org/presentationml/2006/main" xmlns:r="http://schemas.openxmlformats.org/officeDocument/2006/relationships">
-  <p:cSld>
-    <p:spTree>
-      <p:nvGrpSpPr>
-        <p:cNvPr id="1" name=""/>
-        <p:cNvGrpSpPr/>
-        <p:nvPr/>
-      </p:nvGrpSpPr>
-      <p:grpSpPr/>
-      <p:sp>
-        <p:nvSpPr>
-          <p:cNvPr id="2" name="Title 1"/>
-          <p:cNvSpPr>
-            <a:spLocks noGrp="1"/>
-          </p:cNvSpPr>
-          <p:nvPr>
-            <p:ph type="title"/>
-          </p:nvPr>
-        </p:nvSpPr>
-        <p:spPr/>
-        <p:txBody>
-          <a:bodyPr/>
-          <a:lstStyle/>
-          <a:p>
-            <a:r>
-              <a:t>Slide 10: paradigm-shifting ROI</a:t>
-            </a:r>
-          </a:p>
-        </p:txBody>
-      </p:sp>
-      <p:sp>
-        <p:nvSpPr>
-          <p:cNvPr id="3" name="Content Placeholder 2"/>
-          <p:cNvSpPr>
-            <a:spLocks noGrp="1"/>
-          </p:cNvSpPr>
-          <p:nvPr>
-            <p:ph idx="1"/>
-          </p:nvPr>
-        </p:nvSpPr>
-        <p:spPr/>
-        <p:txBody>
-          <a:bodyPr/>
-          <a:lstStyle/>
-          <a:p>
-            <a:r>
-              <a:t>Compliance is at the heart of our bleeding-edge creative disruption system. We utilize hyper-local cultural relevance to verify all claims against regional regulations. [METRIC] Our internal audit scores this workstream at a 85% efficiency rating.</a:t>
-            </a:r>
-          </a:p>
-        </p:txBody>
-      </p:sp>
-    </p:spTree>
-  </p:cSld>
-  <p:clrMapOvr>
-    <a:masterClrMapping/>
-  </p:clrMapOvr>
-</p:sld>
-</file>
-
-<file path=ppt/slides/slide12.xml><?xml version="1.0" encoding="utf-8"?>
-<p:sld xmlns:a="http://schemas.openxmlformats.org/drawingml/2006/main" xmlns:p="http://schemas.openxmlformats.org/presentationml/2006/main" xmlns:r="http://schemas.openxmlformats.org/officeDocument/2006/relationships">
-  <p:cSld>
-    <p:spTree>
-      <p:nvGrpSpPr>
-        <p:cNvPr id="1" name=""/>
-        <p:cNvGrpSpPr/>
-        <p:nvPr/>
-      </p:nvGrpSpPr>
-      <p:grpSpPr/>
-      <p:sp>
-        <p:nvSpPr>
-          <p:cNvPr id="2" name="Title 1"/>
-          <p:cNvSpPr>
-            <a:spLocks noGrp="1"/>
-          </p:cNvSpPr>
-          <p:nvPr>
-            <p:ph type="title"/>
-          </p:nvPr>
-        </p:nvSpPr>
-        <p:spPr/>
-        <p:txBody>
-          <a:bodyPr/>
-          <a:lstStyle/>
-          <a:p>
-            <a:r>
-              <a:t>Slide 11: growth-hacking strategy</a:t>
-            </a:r>
-          </a:p>
-        </p:txBody>
-      </p:sp>
-      <p:sp>
-        <p:nvSpPr>
-          <p:cNvPr id="3" name="Content Placeholder 2"/>
-          <p:cNvSpPr>
-            <a:spLocks noGrp="1"/>
-          </p:cNvSpPr>
-          <p:nvPr>
-            <p:ph idx="1"/>
-          </p:nvPr>
-        </p:nvSpPr>
-        <p:spPr/>
-        <p:txBody>
-          <a:bodyPr/>
-          <a:lstStyle/>
-          <a:p>
-            <a:r>
-              <a:t>Our quantum-leap brand awareness approach ensures that the NutriKid launch will exceed all stakeholder expectations. Through careful growth-hacking strategy and rigorous testing, we have developed a methodology that scales effortlessly.</a:t>
-            </a:r>
-          </a:p>
-        </p:txBody>
-      </p:sp>
-    </p:spTree>
-  </p:cSld>
-  <p:clrMapOvr>
-    <a:masterClrMapping/>
-  </p:clrMapOvr>
-</p:sld>
-</file>
-
-<file path=ppt/slides/slide13.xml><?xml version="1.0" encoding="utf-8"?>
-<p:sld xmlns:a="http://schemas.openxmlformats.org/drawingml/2006/main" xmlns:p="http://schemas.openxmlformats.org/presentationml/2006/main" xmlns:r="http://schemas.openxmlformats.org/officeDocument/2006/relationships">
-  <p:cSld>
-    <p:spTree>
-      <p:nvGrpSpPr>
-        <p:cNvPr id="1" name=""/>
-        <p:cNvGrpSpPr/>
-        <p:nvPr/>
-      </p:nvGrpSpPr>
-      <p:grpSpPr/>
-      <p:sp>
-        <p:nvSpPr>
-          <p:cNvPr id="2" name="Title 1"/>
-          <p:cNvSpPr>
-            <a:spLocks noGrp="1"/>
-          </p:cNvSpPr>
-          <p:nvPr>
-            <p:ph type="title"/>
-          </p:nvPr>
-        </p:nvSpPr>
-        <p:spPr/>
-        <p:txBody>
-          <a:bodyPr/>
-          <a:lstStyle/>
-          <a:p>
-            <a:r>
-              <a:t>Slide 12: growth-hacking strategy</a:t>
-            </a:r>
-          </a:p>
-        </p:txBody>
-      </p:sp>
-      <p:sp>
-        <p:nvSpPr>
-          <p:cNvPr id="3" name="Content Placeholder 2"/>
-          <p:cNvSpPr>
-            <a:spLocks noGrp="1"/>
-          </p:cNvSpPr>
-          <p:nvPr>
-            <p:ph idx="1"/>
-          </p:nvPr>
-        </p:nvSpPr>
-        <p:spPr/>
-        <p:txBody>
-          <a:bodyPr/>
-          <a:lstStyle/>
-          <a:p>
-            <a:r>
-              <a:t>Our holistic consumer engagement approach ensures that the NutriKid launch will exceed all stakeholder expectations. Through careful 360-degree brand amplification and rigorous testing, we have developed a methodology that scales effortlessly.</a:t>
-            </a:r>
-          </a:p>
-        </p:txBody>
-      </p:sp>
-    </p:spTree>
-  </p:cSld>
-  <p:clrMapOvr>
-    <a:masterClrMapping/>
-  </p:clrMapOvr>
-</p:sld>
-</file>
-
-<file path=ppt/slides/slide14.xml><?xml version="1.0" encoding="utf-8"?>
-<p:sld xmlns:a="http://schemas.openxmlformats.org/drawingml/2006/main" xmlns:p="http://schemas.openxmlformats.org/presentationml/2006/main" xmlns:r="http://schemas.openxmlformats.org/officeDocument/2006/relationships">
-  <p:cSld>
-    <p:spTree>
-      <p:nvGrpSpPr>
-        <p:cNvPr id="1" name=""/>
-        <p:cNvGrpSpPr/>
-        <p:nvPr/>
-      </p:nvGrpSpPr>
-      <p:grpSpPr/>
-      <p:sp>
-        <p:nvSpPr>
-          <p:cNvPr id="2" name="Title 1"/>
-          <p:cNvSpPr>
-            <a:spLocks noGrp="1"/>
-          </p:cNvSpPr>
-          <p:nvPr>
-            <p:ph type="title"/>
-          </p:nvPr>
-        </p:nvSpPr>
-        <p:spPr/>
-        <p:txBody>
-          <a:bodyPr/>
-          <a:lstStyle/>
-          <a:p>
-            <a:r>
-              <a:t>Slide 13: hyper-local cultural relevance</a:t>
-            </a:r>
-          </a:p>
-        </p:txBody>
-      </p:sp>
-      <p:sp>
-        <p:nvSpPr>
-          <p:cNvPr id="3" name="Content Placeholder 2"/>
-          <p:cNvSpPr>
-            <a:spLocks noGrp="1"/>
-          </p:cNvSpPr>
-          <p:nvPr>
-            <p:ph idx="1"/>
-          </p:nvPr>
-        </p:nvSpPr>
-        <p:spPr/>
-        <p:txBody>
-          <a:bodyPr/>
-          <a:lstStyle/>
-          <a:p>
-            <a:r>
-              <a:t>Regarding the strategy, we believe that agile response framework is the key to unlocking market share in SEA. Our team will deploy hyper-local cultural relevance to maximize reach. [METRIC] Our internal audit scores this workstream at a 80% efficiency rating.</a:t>
-            </a:r>
-          </a:p>
-        </p:txBody>
-      </p:sp>
-    </p:spTree>
-  </p:cSld>
-  <p:clrMapOvr>
-    <a:masterClrMapping/>
-  </p:clrMapOvr>
-</p:sld>
-</file>
-
-<file path=ppt/slides/slide15.xml><?xml version="1.0" encoding="utf-8"?>
-<p:sld xmlns:a="http://schemas.openxmlformats.org/drawingml/2006/main" xmlns:p="http://schemas.openxmlformats.org/presentationml/2006/main" xmlns:r="http://schemas.openxmlformats.org/officeDocument/2006/relationships">
-  <p:cSld>
-    <p:spTree>
-      <p:nvGrpSpPr>
-        <p:cNvPr id="1" name=""/>
-        <p:cNvGrpSpPr/>
-        <p:nvPr/>
-      </p:nvGrpSpPr>
-      <p:grpSpPr/>
-      <p:sp>
-        <p:nvSpPr>
-          <p:cNvPr id="2" name="Title 1"/>
-          <p:cNvSpPr>
-            <a:spLocks noGrp="1"/>
-          </p:cNvSpPr>
-          <p:nvPr>
-            <p:ph type="title"/>
-          </p:nvPr>
-        </p:nvSpPr>
-        <p:spPr/>
-        <p:txBody>
-          <a:bodyPr/>
-          <a:lstStyle/>
-          <a:p>
-            <a:r>
-              <a:t>Slide 14: quantum-leap brand awareness</a:t>
-            </a:r>
-          </a:p>
-        </p:txBody>
-      </p:sp>
-      <p:sp>
-        <p:nvSpPr>
-          <p:cNvPr id="3" name="Content Placeholder 2"/>
-          <p:cNvSpPr>
-            <a:spLocks noGrp="1"/>
-          </p:cNvSpPr>
-          <p:nvPr>
-            <p:ph idx="1"/>
-          </p:nvPr>
-        </p:nvSpPr>
-        <p:spPr/>
-        <p:txBody>
-          <a:bodyPr/>
-          <a:lstStyle/>
-          <a:p>
-            <a:r>
-              <a:t>Our growth-hacking strategy approach ensures that the NutriKid launch will exceed all stakeholder expectations. Through careful bleeding-edge creative disruption and rigorous testing, we have developed a methodology that scales effortlessly.</a:t>
-            </a:r>
-          </a:p>
-        </p:txBody>
-      </p:sp>
-    </p:spTree>
-  </p:cSld>
-  <p:clrMapOvr>
-    <a:masterClrMapping/>
-  </p:clrMapOvr>
-</p:sld>
-</file>
-
-<file path=ppt/slides/slide16.xml><?xml version="1.0" encoding="utf-8"?>
-<p:sld xmlns:a="http://schemas.openxmlformats.org/drawingml/2006/main" xmlns:p="http://schemas.openxmlformats.org/presentationml/2006/main" xmlns:r="http://schemas.openxmlformats.org/officeDocument/2006/relationships">
-  <p:cSld>
-    <p:spTree>
-      <p:nvGrpSpPr>
-        <p:cNvPr id="1" name=""/>
-        <p:cNvGrpSpPr/>
-        <p:nvPr/>
-      </p:nvGrpSpPr>
-      <p:grpSpPr/>
-      <p:sp>
-        <p:nvSpPr>
-          <p:cNvPr id="2" name="Title 1"/>
-          <p:cNvSpPr>
-            <a:spLocks noGrp="1"/>
-          </p:cNvSpPr>
-          <p:nvPr>
-            <p:ph type="title"/>
-          </p:nvPr>
-        </p:nvSpPr>
-        <p:spPr/>
-        <p:txBody>
-          <a:bodyPr/>
-          <a:lstStyle/>
-          <a:p>
-            <a:r>
-              <a:t>Slide 15: paradigm-shifting ROI</a:t>
-            </a:r>
-          </a:p>
-        </p:txBody>
-      </p:sp>
-      <p:sp>
-        <p:nvSpPr>
-          <p:cNvPr id="3" name="Content Placeholder 2"/>
-          <p:cNvSpPr>
-            <a:spLocks noGrp="1"/>
-          </p:cNvSpPr>
-          <p:nvPr>
-            <p:ph idx="1"/>
-          </p:nvPr>
-        </p:nvSpPr>
-        <p:spPr/>
-        <p:txBody>
-          <a:bodyPr/>
-          <a:lstStyle/>
-          <a:p>
-            <a:r>
-              <a:t>The technical specifications for the TVC production involve omni-channel synergy across all regional hubs. This allows for a data-driven market penetration that is both cost-effective and high-impact.</a:t>
-            </a:r>
-          </a:p>
-        </p:txBody>
-      </p:sp>
-    </p:spTree>
-  </p:cSld>
-  <p:clrMapOvr>
-    <a:masterClrMapping/>
-  </p:clrMapOvr>
-</p:sld>
-</file>
-
-<file path=ppt/slides/slide17.xml><?xml version="1.0" encoding="utf-8"?>
-<p:sld xmlns:a="http://schemas.openxmlformats.org/drawingml/2006/main" xmlns:p="http://schemas.openxmlformats.org/presentationml/2006/main" xmlns:r="http://schemas.openxmlformats.org/officeDocument/2006/relationships">
-  <p:cSld>
-    <p:spTree>
-      <p:nvGrpSpPr>
-        <p:cNvPr id="1" name=""/>
-        <p:cNvGrpSpPr/>
-        <p:nvPr/>
-      </p:nvGrpSpPr>
-      <p:grpSpPr/>
-      <p:sp>
-        <p:nvSpPr>
-          <p:cNvPr id="2" name="Title 1"/>
-          <p:cNvSpPr>
-            <a:spLocks noGrp="1"/>
-          </p:cNvSpPr>
-          <p:nvPr>
-            <p:ph type="title"/>
-          </p:nvPr>
-        </p:nvSpPr>
-        <p:spPr/>
-        <p:txBody>
-          <a:bodyPr/>
-          <a:lstStyle/>
-          <a:p>
-            <a:r>
-              <a:t>Slide 16: agile response framework</a:t>
-            </a:r>
-          </a:p>
-        </p:txBody>
-      </p:sp>
-      <p:sp>
-        <p:nvSpPr>
-          <p:cNvPr id="3" name="Content Placeholder 2"/>
-          <p:cNvSpPr>
-            <a:spLocks noGrp="1"/>
-          </p:cNvSpPr>
-          <p:nvPr>
-            <p:ph idx="1"/>
-          </p:nvPr>
-        </p:nvSpPr>
-        <p:spPr/>
-        <p:txBody>
-          <a:bodyPr/>
-          <a:lstStyle/>
-          <a:p>
-            <a:r>
-              <a:t>The technical specifications for the TVC production involve quantum-leap brand awareness across all regional hubs. This allows for a seamless platform integration that is both cost-effective and high-impact. [METRIC] Our internal audit scores this workstream at a 92% efficiency rating.</a:t>
-            </a:r>
-          </a:p>
-        </p:txBody>
-      </p:sp>
-    </p:spTree>
-  </p:cSld>
-  <p:clrMapOvr>
-    <a:masterClrMapping/>
-  </p:clrMapOvr>
-</p:sld>
-</file>
-
-<file path=ppt/slides/slide18.xml><?xml version="1.0" encoding="utf-8"?>
-<p:sld xmlns:a="http://schemas.openxmlformats.org/drawingml/2006/main" xmlns:p="http://schemas.openxmlformats.org/presentationml/2006/main" xmlns:r="http://schemas.openxmlformats.org/officeDocument/2006/relationships">
-  <p:cSld>
-    <p:spTree>
-      <p:nvGrpSpPr>
-        <p:cNvPr id="1" name=""/>
-        <p:cNvGrpSpPr/>
-        <p:nvPr/>
-      </p:nvGrpSpPr>
-      <p:grpSpPr/>
-      <p:sp>
-        <p:nvSpPr>
-          <p:cNvPr id="2" name="Title 1"/>
-          <p:cNvSpPr>
-            <a:spLocks noGrp="1"/>
-          </p:cNvSpPr>
-          <p:nvPr>
-            <p:ph type="title"/>
-          </p:nvPr>
-        </p:nvSpPr>
-        <p:spPr/>
-        <p:txBody>
-          <a:bodyPr/>
-          <a:lstStyle/>
-          <a:p>
-            <a:r>
-              <a:t>Slide 17: agile response framework</a:t>
-            </a:r>
-          </a:p>
-        </p:txBody>
-      </p:sp>
-      <p:sp>
-        <p:nvSpPr>
-          <p:cNvPr id="3" name="Content Placeholder 2"/>
-          <p:cNvSpPr>
-            <a:spLocks noGrp="1"/>
-          </p:cNvSpPr>
-          <p:nvPr>
-            <p:ph idx="1"/>
-          </p:nvPr>
-        </p:nvSpPr>
-        <p:spPr/>
-        <p:txBody>
-          <a:bodyPr/>
-          <a:lstStyle/>
-          <a:p>
-            <a:r>
-              <a:t>Our 360-degree brand amplification approach ensures that the NutriKid launch will exceed all stakeholder expectations. Through careful paradigm-shifting ROI and rigorous testing, we have developed a methodology that scales effortlessly.</a:t>
-            </a:r>
-          </a:p>
-          <a:p>
-            <a:pPr>
-              <a:defRPr b="1"/>
-            </a:pPr>
-            <a:r>
-              <a:t>PROPOSED INVESTMENT for TVC: $300,000 (Ref: SOW-X-16)</a:t>
-            </a:r>
-          </a:p>
-        </p:txBody>
-      </p:sp>
-    </p:spTree>
-  </p:cSld>
-  <p:clrMapOvr>
-    <a:masterClrMapping/>
-  </p:clrMapOvr>
-</p:sld>
-</file>
-
-<file path=ppt/slides/slide19.xml><?xml version="1.0" encoding="utf-8"?>
-<p:sld xmlns:a="http://schemas.openxmlformats.org/drawingml/2006/main" xmlns:p="http://schemas.openxmlformats.org/presentationml/2006/main" xmlns:r="http://schemas.openxmlformats.org/officeDocument/2006/relationships">
-  <p:cSld>
-    <p:spTree>
-      <p:nvGrpSpPr>
-        <p:cNvPr id="1" name=""/>
-        <p:cNvGrpSpPr/>
-        <p:nvPr/>
-      </p:nvGrpSpPr>
-      <p:grpSpPr/>
-      <p:sp>
-        <p:nvSpPr>
-          <p:cNvPr id="2" name="Title 1"/>
-          <p:cNvSpPr>
-            <a:spLocks noGrp="1"/>
-          </p:cNvSpPr>
-          <p:nvPr>
-            <p:ph type="title"/>
-          </p:nvPr>
-        </p:nvSpPr>
-        <p:spPr/>
-        <p:txBody>
-          <a:bodyPr/>
-          <a:lstStyle/>
-          <a:p>
-            <a:r>
-              <a:t>Slide 18: synergistic touchpoints</a:t>
-            </a:r>
-          </a:p>
-        </p:txBody>
-      </p:sp>
-      <p:sp>
-        <p:nvSpPr>
-          <p:cNvPr id="3" name="Content Placeholder 2"/>
-          <p:cNvSpPr>
-            <a:spLocks noGrp="1"/>
-          </p:cNvSpPr>
-          <p:nvPr>
-            <p:ph idx="1"/>
-          </p:nvPr>
-        </p:nvSpPr>
-        <p:spPr/>
-        <p:txBody>
-          <a:bodyPr/>
-          <a:lstStyle/>
-          <a:p>
-            <a:r>
-              <a:t>Our hyper-local cultural relevance approach ensures that the NutriKid launch will exceed all stakeholder expectations. Through careful seamless platform integration and rigorous testing, we have developed a methodology that scales effortlessly.</a:t>
+              <a:t>SOW Alignment &amp; Technical Methodology</a:t>
             </a:r>
           </a:p>
         </p:txBody>
@@ -3820,7 +3171,7 @@
           <a:lstStyle/>
           <a:p>
             <a:r>
-              <a:t>Slide 1: omni-channel synergy</a:t>
+              <a:t>Strategy &amp; Creative Development Framework</a:t>
             </a:r>
           </a:p>
         </p:txBody>
@@ -3841,623 +3192,12 @@
           <a:lstStyle/>
           <a:p>
             <a:r>
-              <a:t>Regarding the strategy, we believe that bleeding-edge creative disruption is the key to unlocking market share in SEA. Our team will deploy 360-degree brand amplification to maximize reach. [METRIC] Our internal audit scores this workstream at a 92% efficiency rating.</a:t>
-            </a:r>
-          </a:p>
-          <a:p>
-            <a:pPr>
-              <a:defRPr b="1"/>
-            </a:pPr>
-            <a:r>
-              <a:t>PROPOSED INVESTMENT for Social: $120,000 (Ref: SOW-X-0)</a:t>
-            </a:r>
-          </a:p>
-        </p:txBody>
-      </p:sp>
-    </p:spTree>
-  </p:cSld>
-  <p:clrMapOvr>
-    <a:masterClrMapping/>
-  </p:clrMapOvr>
-</p:sld>
-</file>
-
-<file path=ppt/slides/slide20.xml><?xml version="1.0" encoding="utf-8"?>
-<p:sld xmlns:a="http://schemas.openxmlformats.org/drawingml/2006/main" xmlns:p="http://schemas.openxmlformats.org/presentationml/2006/main" xmlns:r="http://schemas.openxmlformats.org/officeDocument/2006/relationships">
-  <p:cSld>
-    <p:spTree>
-      <p:nvGrpSpPr>
-        <p:cNvPr id="1" name=""/>
-        <p:cNvGrpSpPr/>
-        <p:nvPr/>
-      </p:nvGrpSpPr>
-      <p:grpSpPr/>
-      <p:sp>
-        <p:nvSpPr>
-          <p:cNvPr id="2" name="Title 1"/>
-          <p:cNvSpPr>
-            <a:spLocks noGrp="1"/>
-          </p:cNvSpPr>
-          <p:nvPr>
-            <p:ph type="title"/>
-          </p:nvPr>
-        </p:nvSpPr>
-        <p:spPr/>
-        <p:txBody>
-          <a:bodyPr/>
-          <a:lstStyle/>
-          <a:p>
-            <a:r>
-              <a:t>Slide 19: holistic consumer engagement</a:t>
-            </a:r>
-          </a:p>
-        </p:txBody>
-      </p:sp>
-      <p:sp>
-        <p:nvSpPr>
-          <p:cNvPr id="3" name="Content Placeholder 2"/>
-          <p:cNvSpPr>
-            <a:spLocks noGrp="1"/>
-          </p:cNvSpPr>
-          <p:nvPr>
-            <p:ph idx="1"/>
-          </p:nvPr>
-        </p:nvSpPr>
-        <p:spPr/>
-        <p:txBody>
-          <a:bodyPr/>
-          <a:lstStyle/>
-          <a:p>
-            <a:r>
-              <a:t>The technical specifications for the TVC production involve quantum-leap brand awareness across all regional hubs. This allows for a growth-hacking strategy that is both cost-effective and high-impact.</a:t>
-            </a:r>
-          </a:p>
-        </p:txBody>
-      </p:sp>
-    </p:spTree>
-  </p:cSld>
-  <p:clrMapOvr>
-    <a:masterClrMapping/>
-  </p:clrMapOvr>
-</p:sld>
-</file>
-
-<file path=ppt/slides/slide21.xml><?xml version="1.0" encoding="utf-8"?>
-<p:sld xmlns:a="http://schemas.openxmlformats.org/drawingml/2006/main" xmlns:p="http://schemas.openxmlformats.org/presentationml/2006/main" xmlns:r="http://schemas.openxmlformats.org/officeDocument/2006/relationships">
-  <p:cSld>
-    <p:spTree>
-      <p:nvGrpSpPr>
-        <p:cNvPr id="1" name=""/>
-        <p:cNvGrpSpPr/>
-        <p:nvPr/>
-      </p:nvGrpSpPr>
-      <p:grpSpPr/>
-      <p:sp>
-        <p:nvSpPr>
-          <p:cNvPr id="2" name="Title 1"/>
-          <p:cNvSpPr>
-            <a:spLocks noGrp="1"/>
-          </p:cNvSpPr>
-          <p:nvPr>
-            <p:ph type="title"/>
-          </p:nvPr>
-        </p:nvSpPr>
-        <p:spPr/>
-        <p:txBody>
-          <a:bodyPr/>
-          <a:lstStyle/>
-          <a:p>
-            <a:r>
-              <a:t>Slide 20: agile response framework</a:t>
-            </a:r>
-          </a:p>
-        </p:txBody>
-      </p:sp>
-      <p:sp>
-        <p:nvSpPr>
-          <p:cNvPr id="3" name="Content Placeholder 2"/>
-          <p:cNvSpPr>
-            <a:spLocks noGrp="1"/>
-          </p:cNvSpPr>
-          <p:nvPr>
-            <p:ph idx="1"/>
-          </p:nvPr>
-        </p:nvSpPr>
-        <p:spPr/>
-        <p:txBody>
-          <a:bodyPr/>
-          <a:lstStyle/>
-          <a:p>
-            <a:r>
-              <a:t>Regarding the strategy, we believe that growth-hacking strategy is the key to unlocking market share in SEA. Our team will deploy bleeding-edge creative disruption to maximize reach.</a:t>
-            </a:r>
-          </a:p>
-        </p:txBody>
-      </p:sp>
-    </p:spTree>
-  </p:cSld>
-  <p:clrMapOvr>
-    <a:masterClrMapping/>
-  </p:clrMapOvr>
-</p:sld>
-</file>
-
-<file path=ppt/slides/slide22.xml><?xml version="1.0" encoding="utf-8"?>
-<p:sld xmlns:a="http://schemas.openxmlformats.org/drawingml/2006/main" xmlns:p="http://schemas.openxmlformats.org/presentationml/2006/main" xmlns:r="http://schemas.openxmlformats.org/officeDocument/2006/relationships">
-  <p:cSld>
-    <p:spTree>
-      <p:nvGrpSpPr>
-        <p:cNvPr id="1" name=""/>
-        <p:cNvGrpSpPr/>
-        <p:nvPr/>
-      </p:nvGrpSpPr>
-      <p:grpSpPr/>
-      <p:sp>
-        <p:nvSpPr>
-          <p:cNvPr id="2" name="Title 1"/>
-          <p:cNvSpPr>
-            <a:spLocks noGrp="1"/>
-          </p:cNvSpPr>
-          <p:nvPr>
-            <p:ph type="title"/>
-          </p:nvPr>
-        </p:nvSpPr>
-        <p:spPr/>
-        <p:txBody>
-          <a:bodyPr/>
-          <a:lstStyle/>
-          <a:p>
-            <a:r>
-              <a:t>Slide 21: 360-degree brand amplification</a:t>
-            </a:r>
-          </a:p>
-        </p:txBody>
-      </p:sp>
-      <p:sp>
-        <p:nvSpPr>
-          <p:cNvPr id="3" name="Content Placeholder 2"/>
-          <p:cNvSpPr>
-            <a:spLocks noGrp="1"/>
-          </p:cNvSpPr>
-          <p:nvPr>
-            <p:ph idx="1"/>
-          </p:nvPr>
-        </p:nvSpPr>
-        <p:spPr/>
-        <p:txBody>
-          <a:bodyPr/>
-          <a:lstStyle/>
-          <a:p>
-            <a:r>
-              <a:t>Our paradigm-shifting ROI approach ensures that the NutriKid launch will exceed all stakeholder expectations. Through careful growth-hacking strategy and rigorous testing, we have developed a methodology that scales effortlessly.</a:t>
-            </a:r>
-          </a:p>
-        </p:txBody>
-      </p:sp>
-    </p:spTree>
-  </p:cSld>
-  <p:clrMapOvr>
-    <a:masterClrMapping/>
-  </p:clrMapOvr>
-</p:sld>
-</file>
-
-<file path=ppt/slides/slide23.xml><?xml version="1.0" encoding="utf-8"?>
-<p:sld xmlns:a="http://schemas.openxmlformats.org/drawingml/2006/main" xmlns:p="http://schemas.openxmlformats.org/presentationml/2006/main" xmlns:r="http://schemas.openxmlformats.org/officeDocument/2006/relationships">
-  <p:cSld>
-    <p:spTree>
-      <p:nvGrpSpPr>
-        <p:cNvPr id="1" name=""/>
-        <p:cNvGrpSpPr/>
-        <p:nvPr/>
-      </p:nvGrpSpPr>
-      <p:grpSpPr/>
-      <p:sp>
-        <p:nvSpPr>
-          <p:cNvPr id="2" name="Title 1"/>
-          <p:cNvSpPr>
-            <a:spLocks noGrp="1"/>
-          </p:cNvSpPr>
-          <p:nvPr>
-            <p:ph type="title"/>
-          </p:nvPr>
-        </p:nvSpPr>
-        <p:spPr/>
-        <p:txBody>
-          <a:bodyPr/>
-          <a:lstStyle/>
-          <a:p>
-            <a:r>
-              <a:t>Slide 22: quantum-leap brand awareness</a:t>
-            </a:r>
-          </a:p>
-        </p:txBody>
-      </p:sp>
-      <p:sp>
-        <p:nvSpPr>
-          <p:cNvPr id="3" name="Content Placeholder 2"/>
-          <p:cNvSpPr>
-            <a:spLocks noGrp="1"/>
-          </p:cNvSpPr>
-          <p:nvPr>
-            <p:ph idx="1"/>
-          </p:nvPr>
-        </p:nvSpPr>
-        <p:spPr/>
-        <p:txBody>
-          <a:bodyPr/>
-          <a:lstStyle/>
-          <a:p>
-            <a:r>
-              <a:t>Our quantum-leap brand awareness approach ensures that the NutriKid launch will exceed all stakeholder expectations. Through careful paradigm-shifting ROI and rigorous testing, we have developed a methodology that scales effortlessly.</a:t>
-            </a:r>
-          </a:p>
-        </p:txBody>
-      </p:sp>
-    </p:spTree>
-  </p:cSld>
-  <p:clrMapOvr>
-    <a:masterClrMapping/>
-  </p:clrMapOvr>
-</p:sld>
-</file>
-
-<file path=ppt/slides/slide24.xml><?xml version="1.0" encoding="utf-8"?>
-<p:sld xmlns:a="http://schemas.openxmlformats.org/drawingml/2006/main" xmlns:p="http://schemas.openxmlformats.org/presentationml/2006/main" xmlns:r="http://schemas.openxmlformats.org/officeDocument/2006/relationships">
-  <p:cSld>
-    <p:spTree>
-      <p:nvGrpSpPr>
-        <p:cNvPr id="1" name=""/>
-        <p:cNvGrpSpPr/>
-        <p:nvPr/>
-      </p:nvGrpSpPr>
-      <p:grpSpPr/>
-      <p:sp>
-        <p:nvSpPr>
-          <p:cNvPr id="2" name="Title 1"/>
-          <p:cNvSpPr>
-            <a:spLocks noGrp="1"/>
-          </p:cNvSpPr>
-          <p:nvPr>
-            <p:ph type="title"/>
-          </p:nvPr>
-        </p:nvSpPr>
-        <p:spPr/>
-        <p:txBody>
-          <a:bodyPr/>
-          <a:lstStyle/>
-          <a:p>
-            <a:r>
-              <a:t>Slide 23: holistic consumer engagement</a:t>
-            </a:r>
-          </a:p>
-        </p:txBody>
-      </p:sp>
-      <p:sp>
-        <p:nvSpPr>
-          <p:cNvPr id="3" name="Content Placeholder 2"/>
-          <p:cNvSpPr>
-            <a:spLocks noGrp="1"/>
-          </p:cNvSpPr>
-          <p:nvPr>
-            <p:ph idx="1"/>
-          </p:nvPr>
-        </p:nvSpPr>
-        <p:spPr/>
-        <p:txBody>
-          <a:bodyPr/>
-          <a:lstStyle/>
-          <a:p>
-            <a:r>
-              <a:t>Our 360-degree brand amplification approach ensures that the NutriKid launch will exceed all stakeholder expectations. Through careful paradigm-shifting ROI and rigorous testing, we have developed a methodology that scales effortlessly.</a:t>
-            </a:r>
-          </a:p>
-        </p:txBody>
-      </p:sp>
-    </p:spTree>
-  </p:cSld>
-  <p:clrMapOvr>
-    <a:masterClrMapping/>
-  </p:clrMapOvr>
-</p:sld>
-</file>
-
-<file path=ppt/slides/slide25.xml><?xml version="1.0" encoding="utf-8"?>
-<p:sld xmlns:a="http://schemas.openxmlformats.org/drawingml/2006/main" xmlns:p="http://schemas.openxmlformats.org/presentationml/2006/main" xmlns:r="http://schemas.openxmlformats.org/officeDocument/2006/relationships">
-  <p:cSld>
-    <p:spTree>
-      <p:nvGrpSpPr>
-        <p:cNvPr id="1" name=""/>
-        <p:cNvGrpSpPr/>
-        <p:nvPr/>
-      </p:nvGrpSpPr>
-      <p:grpSpPr/>
-      <p:sp>
-        <p:nvSpPr>
-          <p:cNvPr id="2" name="Title 1"/>
-          <p:cNvSpPr>
-            <a:spLocks noGrp="1"/>
-          </p:cNvSpPr>
-          <p:nvPr>
-            <p:ph type="title"/>
-          </p:nvPr>
-        </p:nvSpPr>
-        <p:spPr/>
-        <p:txBody>
-          <a:bodyPr/>
-          <a:lstStyle/>
-          <a:p>
-            <a:r>
-              <a:t>Slide 24: bleeding-edge creative disruption</a:t>
-            </a:r>
-          </a:p>
-        </p:txBody>
-      </p:sp>
-      <p:sp>
-        <p:nvSpPr>
-          <p:cNvPr id="3" name="Content Placeholder 2"/>
-          <p:cNvSpPr>
-            <a:spLocks noGrp="1"/>
-          </p:cNvSpPr>
-          <p:nvPr>
-            <p:ph idx="1"/>
-          </p:nvPr>
-        </p:nvSpPr>
-        <p:spPr/>
-        <p:txBody>
-          <a:bodyPr/>
-          <a:lstStyle/>
-          <a:p>
-            <a:r>
-              <a:t>Compliance is at the heart of our omni-channel synergy system. We utilize agile response framework to verify all claims against regional regulations.</a:t>
-            </a:r>
-          </a:p>
-        </p:txBody>
-      </p:sp>
-    </p:spTree>
-  </p:cSld>
-  <p:clrMapOvr>
-    <a:masterClrMapping/>
-  </p:clrMapOvr>
-</p:sld>
-</file>
-
-<file path=ppt/slides/slide26.xml><?xml version="1.0" encoding="utf-8"?>
-<p:sld xmlns:a="http://schemas.openxmlformats.org/drawingml/2006/main" xmlns:p="http://schemas.openxmlformats.org/presentationml/2006/main" xmlns:r="http://schemas.openxmlformats.org/officeDocument/2006/relationships">
-  <p:cSld>
-    <p:spTree>
-      <p:nvGrpSpPr>
-        <p:cNvPr id="1" name=""/>
-        <p:cNvGrpSpPr/>
-        <p:nvPr/>
-      </p:nvGrpSpPr>
-      <p:grpSpPr/>
-      <p:sp>
-        <p:nvSpPr>
-          <p:cNvPr id="2" name="Title 1"/>
-          <p:cNvSpPr>
-            <a:spLocks noGrp="1"/>
-          </p:cNvSpPr>
-          <p:nvPr>
-            <p:ph type="title"/>
-          </p:nvPr>
-        </p:nvSpPr>
-        <p:spPr/>
-        <p:txBody>
-          <a:bodyPr/>
-          <a:lstStyle/>
-          <a:p>
-            <a:r>
-              <a:t>Slide 25: synergistic touchpoints</a:t>
-            </a:r>
-          </a:p>
-        </p:txBody>
-      </p:sp>
-      <p:sp>
-        <p:nvSpPr>
-          <p:cNvPr id="3" name="Content Placeholder 2"/>
-          <p:cNvSpPr>
-            <a:spLocks noGrp="1"/>
-          </p:cNvSpPr>
-          <p:nvPr>
-            <p:ph idx="1"/>
-          </p:nvPr>
-        </p:nvSpPr>
-        <p:spPr/>
-        <p:txBody>
-          <a:bodyPr/>
-          <a:lstStyle/>
-          <a:p>
-            <a:r>
-              <a:t>Compliance is at the heart of our 360-degree brand amplification system. We utilize hyper-local cultural relevance to verify all claims against regional regulations.</a:t>
-            </a:r>
-          </a:p>
-          <a:p>
-            <a:pPr>
-              <a:defRPr b="1"/>
-            </a:pPr>
-            <a:r>
-              <a:t>PROPOSED INVESTMENT for Compliance: $25,000 (Ref: SOW-X-24)</a:t>
-            </a:r>
-          </a:p>
-        </p:txBody>
-      </p:sp>
-    </p:spTree>
-  </p:cSld>
-  <p:clrMapOvr>
-    <a:masterClrMapping/>
-  </p:clrMapOvr>
-</p:sld>
-</file>
-
-<file path=ppt/slides/slide27.xml><?xml version="1.0" encoding="utf-8"?>
-<p:sld xmlns:a="http://schemas.openxmlformats.org/drawingml/2006/main" xmlns:p="http://schemas.openxmlformats.org/presentationml/2006/main" xmlns:r="http://schemas.openxmlformats.org/officeDocument/2006/relationships">
-  <p:cSld>
-    <p:spTree>
-      <p:nvGrpSpPr>
-        <p:cNvPr id="1" name=""/>
-        <p:cNvGrpSpPr/>
-        <p:nvPr/>
-      </p:nvGrpSpPr>
-      <p:grpSpPr/>
-      <p:sp>
-        <p:nvSpPr>
-          <p:cNvPr id="2" name="Title 1"/>
-          <p:cNvSpPr>
-            <a:spLocks noGrp="1"/>
-          </p:cNvSpPr>
-          <p:nvPr>
-            <p:ph type="title"/>
-          </p:nvPr>
-        </p:nvSpPr>
-        <p:spPr/>
-        <p:txBody>
-          <a:bodyPr/>
-          <a:lstStyle/>
-          <a:p>
-            <a:r>
-              <a:t>Slide 26: synergistic touchpoints</a:t>
-            </a:r>
-          </a:p>
-        </p:txBody>
-      </p:sp>
-      <p:sp>
-        <p:nvSpPr>
-          <p:cNvPr id="3" name="Content Placeholder 2"/>
-          <p:cNvSpPr>
-            <a:spLocks noGrp="1"/>
-          </p:cNvSpPr>
-          <p:nvPr>
-            <p:ph idx="1"/>
-          </p:nvPr>
-        </p:nvSpPr>
-        <p:spPr/>
-        <p:txBody>
-          <a:bodyPr/>
-          <a:lstStyle/>
-          <a:p>
-            <a:r>
-              <a:t>Regarding the strategy, we believe that holistic consumer engagement is the key to unlocking market share in SEA. Our team will deploy agile response framework to maximize reach.</a:t>
-            </a:r>
-          </a:p>
-        </p:txBody>
-      </p:sp>
-    </p:spTree>
-  </p:cSld>
-  <p:clrMapOvr>
-    <a:masterClrMapping/>
-  </p:clrMapOvr>
-</p:sld>
-</file>
-
-<file path=ppt/slides/slide28.xml><?xml version="1.0" encoding="utf-8"?>
-<p:sld xmlns:a="http://schemas.openxmlformats.org/drawingml/2006/main" xmlns:p="http://schemas.openxmlformats.org/presentationml/2006/main" xmlns:r="http://schemas.openxmlformats.org/officeDocument/2006/relationships">
-  <p:cSld>
-    <p:spTree>
-      <p:nvGrpSpPr>
-        <p:cNvPr id="1" name=""/>
-        <p:cNvGrpSpPr/>
-        <p:nvPr/>
-      </p:nvGrpSpPr>
-      <p:grpSpPr/>
-      <p:sp>
-        <p:nvSpPr>
-          <p:cNvPr id="2" name="Title 1"/>
-          <p:cNvSpPr>
-            <a:spLocks noGrp="1"/>
-          </p:cNvSpPr>
-          <p:nvPr>
-            <p:ph type="title"/>
-          </p:nvPr>
-        </p:nvSpPr>
-        <p:spPr/>
-        <p:txBody>
-          <a:bodyPr/>
-          <a:lstStyle/>
-          <a:p>
-            <a:r>
-              <a:t>Slide 27: holistic consumer engagement</a:t>
-            </a:r>
-          </a:p>
-        </p:txBody>
-      </p:sp>
-      <p:sp>
-        <p:nvSpPr>
-          <p:cNvPr id="3" name="Content Placeholder 2"/>
-          <p:cNvSpPr>
-            <a:spLocks noGrp="1"/>
-          </p:cNvSpPr>
-          <p:nvPr>
-            <p:ph idx="1"/>
-          </p:nvPr>
-        </p:nvSpPr>
-        <p:spPr/>
-        <p:txBody>
-          <a:bodyPr/>
-          <a:lstStyle/>
-          <a:p>
-            <a:r>
-              <a:t>Compliance is at the heart of our hyper-local cultural relevance system. We utilize 360-degree brand amplification to verify all claims against regional regulations.</a:t>
-            </a:r>
-          </a:p>
-        </p:txBody>
-      </p:sp>
-    </p:spTree>
-  </p:cSld>
-  <p:clrMapOvr>
-    <a:masterClrMapping/>
-  </p:clrMapOvr>
-</p:sld>
-</file>
-
-<file path=ppt/slides/slide29.xml><?xml version="1.0" encoding="utf-8"?>
-<p:sld xmlns:a="http://schemas.openxmlformats.org/drawingml/2006/main" xmlns:p="http://schemas.openxmlformats.org/presentationml/2006/main" xmlns:r="http://schemas.openxmlformats.org/officeDocument/2006/relationships">
-  <p:cSld>
-    <p:spTree>
-      <p:nvGrpSpPr>
-        <p:cNvPr id="1" name=""/>
-        <p:cNvGrpSpPr/>
-        <p:nvPr/>
-      </p:nvGrpSpPr>
-      <p:grpSpPr/>
-      <p:sp>
-        <p:nvSpPr>
-          <p:cNvPr id="2" name="Title 1"/>
-          <p:cNvSpPr>
-            <a:spLocks noGrp="1"/>
-          </p:cNvSpPr>
-          <p:nvPr>
-            <p:ph type="title"/>
-          </p:nvPr>
-        </p:nvSpPr>
-        <p:spPr/>
-        <p:txBody>
-          <a:bodyPr/>
-          <a:lstStyle/>
-          <a:p>
-            <a:r>
-              <a:t>Slide 28: holistic consumer engagement</a:t>
-            </a:r>
-          </a:p>
-        </p:txBody>
-      </p:sp>
-      <p:sp>
-        <p:nvSpPr>
-          <p:cNvPr id="3" name="Content Placeholder 2"/>
-          <p:cNvSpPr>
-            <a:spLocks noGrp="1"/>
-          </p:cNvSpPr>
-          <p:nvPr>
-            <p:ph idx="1"/>
-          </p:nvPr>
-        </p:nvSpPr>
-        <p:spPr/>
-        <p:txBody>
-          <a:bodyPr/>
-          <a:lstStyle/>
-          <a:p>
-            <a:r>
-              <a:t>Compliance is at the heart of our growth-hacking strategy system. We utilize omni-channel synergy to verify all claims against regional regulations.</a:t>
+              <a:t>Our data-driven market penetration approach ensures that the NutriKid launch will exceed all stakeholder expectations. Through careful 360-degree brand amplification and rigorous testing, we have developed a methodology that scales effortlessly. [COMMERCIAL] The itemized fee for Strategy &amp; Creative Development is projected at $81,161 inclusive of agency overhead but excluding third-party pass-throughs.</a:t>
+            </a:r>
+          </a:p>
+          <a:p>
+            <a:r>
+              <a:t>Key Metric for Strategy &amp; Creative Development: 92% confidence interval.</a:t>
             </a:r>
           </a:p>
         </p:txBody>
@@ -4496,7 +3236,7 @@
           <a:lstStyle/>
           <a:p>
             <a:r>
-              <a:t>Slide 2: paradigm-shifting ROI</a:t>
+              <a:t>TVC Development Framework</a:t>
             </a:r>
           </a:p>
         </p:txBody>
@@ -4517,615 +3257,12 @@
           <a:lstStyle/>
           <a:p>
             <a:r>
-              <a:t>Compliance is at the heart of our hyper-local cultural relevance system. We utilize omni-channel synergy to verify all claims against regional regulations.</a:t>
-            </a:r>
-          </a:p>
-        </p:txBody>
-      </p:sp>
-    </p:spTree>
-  </p:cSld>
-  <p:clrMapOvr>
-    <a:masterClrMapping/>
-  </p:clrMapOvr>
-</p:sld>
-</file>
-
-<file path=ppt/slides/slide30.xml><?xml version="1.0" encoding="utf-8"?>
-<p:sld xmlns:a="http://schemas.openxmlformats.org/drawingml/2006/main" xmlns:p="http://schemas.openxmlformats.org/presentationml/2006/main" xmlns:r="http://schemas.openxmlformats.org/officeDocument/2006/relationships">
-  <p:cSld>
-    <p:spTree>
-      <p:nvGrpSpPr>
-        <p:cNvPr id="1" name=""/>
-        <p:cNvGrpSpPr/>
-        <p:nvPr/>
-      </p:nvGrpSpPr>
-      <p:grpSpPr/>
-      <p:sp>
-        <p:nvSpPr>
-          <p:cNvPr id="2" name="Title 1"/>
-          <p:cNvSpPr>
-            <a:spLocks noGrp="1"/>
-          </p:cNvSpPr>
-          <p:nvPr>
-            <p:ph type="title"/>
-          </p:nvPr>
-        </p:nvSpPr>
-        <p:spPr/>
-        <p:txBody>
-          <a:bodyPr/>
-          <a:lstStyle/>
-          <a:p>
-            <a:r>
-              <a:t>Slide 29: seamless platform integration</a:t>
-            </a:r>
-          </a:p>
-        </p:txBody>
-      </p:sp>
-      <p:sp>
-        <p:nvSpPr>
-          <p:cNvPr id="3" name="Content Placeholder 2"/>
-          <p:cNvSpPr>
-            <a:spLocks noGrp="1"/>
-          </p:cNvSpPr>
-          <p:nvPr>
-            <p:ph idx="1"/>
-          </p:nvPr>
-        </p:nvSpPr>
-        <p:spPr/>
-        <p:txBody>
-          <a:bodyPr/>
-          <a:lstStyle/>
-          <a:p>
-            <a:r>
-              <a:t>The technical specifications for the TVC production involve data-driven market penetration across all regional hubs. This allows for a omni-channel synergy that is both cost-effective and high-impact.</a:t>
-            </a:r>
-          </a:p>
-        </p:txBody>
-      </p:sp>
-    </p:spTree>
-  </p:cSld>
-  <p:clrMapOvr>
-    <a:masterClrMapping/>
-  </p:clrMapOvr>
-</p:sld>
-</file>
-
-<file path=ppt/slides/slide31.xml><?xml version="1.0" encoding="utf-8"?>
-<p:sld xmlns:a="http://schemas.openxmlformats.org/drawingml/2006/main" xmlns:p="http://schemas.openxmlformats.org/presentationml/2006/main" xmlns:r="http://schemas.openxmlformats.org/officeDocument/2006/relationships">
-  <p:cSld>
-    <p:spTree>
-      <p:nvGrpSpPr>
-        <p:cNvPr id="1" name=""/>
-        <p:cNvGrpSpPr/>
-        <p:nvPr/>
-      </p:nvGrpSpPr>
-      <p:grpSpPr/>
-      <p:sp>
-        <p:nvSpPr>
-          <p:cNvPr id="2" name="Title 1"/>
-          <p:cNvSpPr>
-            <a:spLocks noGrp="1"/>
-          </p:cNvSpPr>
-          <p:nvPr>
-            <p:ph type="title"/>
-          </p:nvPr>
-        </p:nvSpPr>
-        <p:spPr/>
-        <p:txBody>
-          <a:bodyPr/>
-          <a:lstStyle/>
-          <a:p>
-            <a:r>
-              <a:t>Slide 30: agile response framework</a:t>
-            </a:r>
-          </a:p>
-        </p:txBody>
-      </p:sp>
-      <p:sp>
-        <p:nvSpPr>
-          <p:cNvPr id="3" name="Content Placeholder 2"/>
-          <p:cNvSpPr>
-            <a:spLocks noGrp="1"/>
-          </p:cNvSpPr>
-          <p:nvPr>
-            <p:ph idx="1"/>
-          </p:nvPr>
-        </p:nvSpPr>
-        <p:spPr/>
-        <p:txBody>
-          <a:bodyPr/>
-          <a:lstStyle/>
-          <a:p>
-            <a:r>
-              <a:t>Our agile response framework approach ensures that the NutriKid launch will exceed all stakeholder expectations. Through careful bleeding-edge creative disruption and rigorous testing, we have developed a methodology that scales effortlessly.</a:t>
-            </a:r>
-          </a:p>
-        </p:txBody>
-      </p:sp>
-    </p:spTree>
-  </p:cSld>
-  <p:clrMapOvr>
-    <a:masterClrMapping/>
-  </p:clrMapOvr>
-</p:sld>
-</file>
-
-<file path=ppt/slides/slide32.xml><?xml version="1.0" encoding="utf-8"?>
-<p:sld xmlns:a="http://schemas.openxmlformats.org/drawingml/2006/main" xmlns:p="http://schemas.openxmlformats.org/presentationml/2006/main" xmlns:r="http://schemas.openxmlformats.org/officeDocument/2006/relationships">
-  <p:cSld>
-    <p:spTree>
-      <p:nvGrpSpPr>
-        <p:cNvPr id="1" name=""/>
-        <p:cNvGrpSpPr/>
-        <p:nvPr/>
-      </p:nvGrpSpPr>
-      <p:grpSpPr/>
-      <p:sp>
-        <p:nvSpPr>
-          <p:cNvPr id="2" name="Title 1"/>
-          <p:cNvSpPr>
-            <a:spLocks noGrp="1"/>
-          </p:cNvSpPr>
-          <p:nvPr>
-            <p:ph type="title"/>
-          </p:nvPr>
-        </p:nvSpPr>
-        <p:spPr/>
-        <p:txBody>
-          <a:bodyPr/>
-          <a:lstStyle/>
-          <a:p>
-            <a:r>
-              <a:t>Slide 31: data-driven market penetration</a:t>
-            </a:r>
-          </a:p>
-        </p:txBody>
-      </p:sp>
-      <p:sp>
-        <p:nvSpPr>
-          <p:cNvPr id="3" name="Content Placeholder 2"/>
-          <p:cNvSpPr>
-            <a:spLocks noGrp="1"/>
-          </p:cNvSpPr>
-          <p:nvPr>
-            <p:ph idx="1"/>
-          </p:nvPr>
-        </p:nvSpPr>
-        <p:spPr/>
-        <p:txBody>
-          <a:bodyPr/>
-          <a:lstStyle/>
-          <a:p>
-            <a:r>
-              <a:t>The technical specifications for the TVC production involve quantum-leap brand awareness across all regional hubs. This allows for a agile response framework that is both cost-effective and high-impact.</a:t>
-            </a:r>
-          </a:p>
-        </p:txBody>
-      </p:sp>
-    </p:spTree>
-  </p:cSld>
-  <p:clrMapOvr>
-    <a:masterClrMapping/>
-  </p:clrMapOvr>
-</p:sld>
-</file>
-
-<file path=ppt/slides/slide33.xml><?xml version="1.0" encoding="utf-8"?>
-<p:sld xmlns:a="http://schemas.openxmlformats.org/drawingml/2006/main" xmlns:p="http://schemas.openxmlformats.org/presentationml/2006/main" xmlns:r="http://schemas.openxmlformats.org/officeDocument/2006/relationships">
-  <p:cSld>
-    <p:spTree>
-      <p:nvGrpSpPr>
-        <p:cNvPr id="1" name=""/>
-        <p:cNvGrpSpPr/>
-        <p:nvPr/>
-      </p:nvGrpSpPr>
-      <p:grpSpPr/>
-      <p:sp>
-        <p:nvSpPr>
-          <p:cNvPr id="2" name="Title 1"/>
-          <p:cNvSpPr>
-            <a:spLocks noGrp="1"/>
-          </p:cNvSpPr>
-          <p:nvPr>
-            <p:ph type="title"/>
-          </p:nvPr>
-        </p:nvSpPr>
-        <p:spPr/>
-        <p:txBody>
-          <a:bodyPr/>
-          <a:lstStyle/>
-          <a:p>
-            <a:r>
-              <a:t>Slide 32: 360-degree brand amplification</a:t>
-            </a:r>
-          </a:p>
-        </p:txBody>
-      </p:sp>
-      <p:sp>
-        <p:nvSpPr>
-          <p:cNvPr id="3" name="Content Placeholder 2"/>
-          <p:cNvSpPr>
-            <a:spLocks noGrp="1"/>
-          </p:cNvSpPr>
-          <p:nvPr>
-            <p:ph idx="1"/>
-          </p:nvPr>
-        </p:nvSpPr>
-        <p:spPr/>
-        <p:txBody>
-          <a:bodyPr/>
-          <a:lstStyle/>
-          <a:p>
-            <a:r>
-              <a:t>Our agile response framework approach ensures that the NutriKid launch will exceed all stakeholder expectations. Through careful paradigm-shifting ROI and rigorous testing, we have developed a methodology that scales effortlessly.</a:t>
-            </a:r>
-          </a:p>
-        </p:txBody>
-      </p:sp>
-    </p:spTree>
-  </p:cSld>
-  <p:clrMapOvr>
-    <a:masterClrMapping/>
-  </p:clrMapOvr>
-</p:sld>
-</file>
-
-<file path=ppt/slides/slide34.xml><?xml version="1.0" encoding="utf-8"?>
-<p:sld xmlns:a="http://schemas.openxmlformats.org/drawingml/2006/main" xmlns:p="http://schemas.openxmlformats.org/presentationml/2006/main" xmlns:r="http://schemas.openxmlformats.org/officeDocument/2006/relationships">
-  <p:cSld>
-    <p:spTree>
-      <p:nvGrpSpPr>
-        <p:cNvPr id="1" name=""/>
-        <p:cNvGrpSpPr/>
-        <p:nvPr/>
-      </p:nvGrpSpPr>
-      <p:grpSpPr/>
-      <p:sp>
-        <p:nvSpPr>
-          <p:cNvPr id="2" name="Title 1"/>
-          <p:cNvSpPr>
-            <a:spLocks noGrp="1"/>
-          </p:cNvSpPr>
-          <p:nvPr>
-            <p:ph type="title"/>
-          </p:nvPr>
-        </p:nvSpPr>
-        <p:spPr/>
-        <p:txBody>
-          <a:bodyPr/>
-          <a:lstStyle/>
-          <a:p>
-            <a:r>
-              <a:t>Slide 33: data-driven market penetration</a:t>
-            </a:r>
-          </a:p>
-        </p:txBody>
-      </p:sp>
-      <p:sp>
-        <p:nvSpPr>
-          <p:cNvPr id="3" name="Content Placeholder 2"/>
-          <p:cNvSpPr>
-            <a:spLocks noGrp="1"/>
-          </p:cNvSpPr>
-          <p:nvPr>
-            <p:ph idx="1"/>
-          </p:nvPr>
-        </p:nvSpPr>
-        <p:spPr/>
-        <p:txBody>
-          <a:bodyPr/>
-          <a:lstStyle/>
-          <a:p>
-            <a:r>
-              <a:t>The technical specifications for the TVC production involve 360-degree brand amplification across all regional hubs. This allows for a agile response framework that is both cost-effective and high-impact.</a:t>
-            </a:r>
-          </a:p>
-          <a:p>
-            <a:pPr>
-              <a:defRPr b="1"/>
-            </a:pPr>
-            <a:r>
-              <a:t>PROPOSED INVESTMENT for Compliance: $25,000 (Ref: SOW-X-32)</a:t>
-            </a:r>
-          </a:p>
-        </p:txBody>
-      </p:sp>
-    </p:spTree>
-  </p:cSld>
-  <p:clrMapOvr>
-    <a:masterClrMapping/>
-  </p:clrMapOvr>
-</p:sld>
-</file>
-
-<file path=ppt/slides/slide35.xml><?xml version="1.0" encoding="utf-8"?>
-<p:sld xmlns:a="http://schemas.openxmlformats.org/drawingml/2006/main" xmlns:p="http://schemas.openxmlformats.org/presentationml/2006/main" xmlns:r="http://schemas.openxmlformats.org/officeDocument/2006/relationships">
-  <p:cSld>
-    <p:spTree>
-      <p:nvGrpSpPr>
-        <p:cNvPr id="1" name=""/>
-        <p:cNvGrpSpPr/>
-        <p:nvPr/>
-      </p:nvGrpSpPr>
-      <p:grpSpPr/>
-      <p:sp>
-        <p:nvSpPr>
-          <p:cNvPr id="2" name="Title 1"/>
-          <p:cNvSpPr>
-            <a:spLocks noGrp="1"/>
-          </p:cNvSpPr>
-          <p:nvPr>
-            <p:ph type="title"/>
-          </p:nvPr>
-        </p:nvSpPr>
-        <p:spPr/>
-        <p:txBody>
-          <a:bodyPr/>
-          <a:lstStyle/>
-          <a:p>
-            <a:r>
-              <a:t>Slide 34: growth-hacking strategy</a:t>
-            </a:r>
-          </a:p>
-        </p:txBody>
-      </p:sp>
-      <p:sp>
-        <p:nvSpPr>
-          <p:cNvPr id="3" name="Content Placeholder 2"/>
-          <p:cNvSpPr>
-            <a:spLocks noGrp="1"/>
-          </p:cNvSpPr>
-          <p:nvPr>
-            <p:ph idx="1"/>
-          </p:nvPr>
-        </p:nvSpPr>
-        <p:spPr/>
-        <p:txBody>
-          <a:bodyPr/>
-          <a:lstStyle/>
-          <a:p>
-            <a:r>
-              <a:t>Regarding the strategy, we believe that quantum-leap brand awareness is the key to unlocking market share in SEA. Our team will deploy bleeding-edge creative disruption to maximize reach. [METRIC] Our internal audit scores this workstream at a 85% efficiency rating.</a:t>
-            </a:r>
-          </a:p>
-        </p:txBody>
-      </p:sp>
-    </p:spTree>
-  </p:cSld>
-  <p:clrMapOvr>
-    <a:masterClrMapping/>
-  </p:clrMapOvr>
-</p:sld>
-</file>
-
-<file path=ppt/slides/slide36.xml><?xml version="1.0" encoding="utf-8"?>
-<p:sld xmlns:a="http://schemas.openxmlformats.org/drawingml/2006/main" xmlns:p="http://schemas.openxmlformats.org/presentationml/2006/main" xmlns:r="http://schemas.openxmlformats.org/officeDocument/2006/relationships">
-  <p:cSld>
-    <p:spTree>
-      <p:nvGrpSpPr>
-        <p:cNvPr id="1" name=""/>
-        <p:cNvGrpSpPr/>
-        <p:nvPr/>
-      </p:nvGrpSpPr>
-      <p:grpSpPr/>
-      <p:sp>
-        <p:nvSpPr>
-          <p:cNvPr id="2" name="Title 1"/>
-          <p:cNvSpPr>
-            <a:spLocks noGrp="1"/>
-          </p:cNvSpPr>
-          <p:nvPr>
-            <p:ph type="title"/>
-          </p:nvPr>
-        </p:nvSpPr>
-        <p:spPr/>
-        <p:txBody>
-          <a:bodyPr/>
-          <a:lstStyle/>
-          <a:p>
-            <a:r>
-              <a:t>Slide 35: quantum-leap brand awareness</a:t>
-            </a:r>
-          </a:p>
-        </p:txBody>
-      </p:sp>
-      <p:sp>
-        <p:nvSpPr>
-          <p:cNvPr id="3" name="Content Placeholder 2"/>
-          <p:cNvSpPr>
-            <a:spLocks noGrp="1"/>
-          </p:cNvSpPr>
-          <p:nvPr>
-            <p:ph idx="1"/>
-          </p:nvPr>
-        </p:nvSpPr>
-        <p:spPr/>
-        <p:txBody>
-          <a:bodyPr/>
-          <a:lstStyle/>
-          <a:p>
-            <a:r>
-              <a:t>Our holistic consumer engagement approach ensures that the NutriKid launch will exceed all stakeholder expectations. Through careful quantum-leap brand awareness and rigorous testing, we have developed a methodology that scales effortlessly. [METRIC] Our internal audit scores this workstream at a 85% efficiency rating.</a:t>
-            </a:r>
-          </a:p>
-        </p:txBody>
-      </p:sp>
-    </p:spTree>
-  </p:cSld>
-  <p:clrMapOvr>
-    <a:masterClrMapping/>
-  </p:clrMapOvr>
-</p:sld>
-</file>
-
-<file path=ppt/slides/slide37.xml><?xml version="1.0" encoding="utf-8"?>
-<p:sld xmlns:a="http://schemas.openxmlformats.org/drawingml/2006/main" xmlns:p="http://schemas.openxmlformats.org/presentationml/2006/main" xmlns:r="http://schemas.openxmlformats.org/officeDocument/2006/relationships">
-  <p:cSld>
-    <p:spTree>
-      <p:nvGrpSpPr>
-        <p:cNvPr id="1" name=""/>
-        <p:cNvGrpSpPr/>
-        <p:nvPr/>
-      </p:nvGrpSpPr>
-      <p:grpSpPr/>
-      <p:sp>
-        <p:nvSpPr>
-          <p:cNvPr id="2" name="Title 1"/>
-          <p:cNvSpPr>
-            <a:spLocks noGrp="1"/>
-          </p:cNvSpPr>
-          <p:nvPr>
-            <p:ph type="title"/>
-          </p:nvPr>
-        </p:nvSpPr>
-        <p:spPr/>
-        <p:txBody>
-          <a:bodyPr/>
-          <a:lstStyle/>
-          <a:p>
-            <a:r>
-              <a:t>Slide 36: quantum-leap brand awareness</a:t>
-            </a:r>
-          </a:p>
-        </p:txBody>
-      </p:sp>
-      <p:sp>
-        <p:nvSpPr>
-          <p:cNvPr id="3" name="Content Placeholder 2"/>
-          <p:cNvSpPr>
-            <a:spLocks noGrp="1"/>
-          </p:cNvSpPr>
-          <p:nvPr>
-            <p:ph idx="1"/>
-          </p:nvPr>
-        </p:nvSpPr>
-        <p:spPr/>
-        <p:txBody>
-          <a:bodyPr/>
-          <a:lstStyle/>
-          <a:p>
-            <a:r>
-              <a:t>Compliance is at the heart of our bleeding-edge creative disruption system. We utilize bleeding-edge creative disruption to verify all claims against regional regulations.</a:t>
-            </a:r>
-          </a:p>
-        </p:txBody>
-      </p:sp>
-    </p:spTree>
-  </p:cSld>
-  <p:clrMapOvr>
-    <a:masterClrMapping/>
-  </p:clrMapOvr>
-</p:sld>
-</file>
-
-<file path=ppt/slides/slide38.xml><?xml version="1.0" encoding="utf-8"?>
-<p:sld xmlns:a="http://schemas.openxmlformats.org/drawingml/2006/main" xmlns:p="http://schemas.openxmlformats.org/presentationml/2006/main" xmlns:r="http://schemas.openxmlformats.org/officeDocument/2006/relationships">
-  <p:cSld>
-    <p:spTree>
-      <p:nvGrpSpPr>
-        <p:cNvPr id="1" name=""/>
-        <p:cNvGrpSpPr/>
-        <p:nvPr/>
-      </p:nvGrpSpPr>
-      <p:grpSpPr/>
-      <p:sp>
-        <p:nvSpPr>
-          <p:cNvPr id="2" name="Title 1"/>
-          <p:cNvSpPr>
-            <a:spLocks noGrp="1"/>
-          </p:cNvSpPr>
-          <p:nvPr>
-            <p:ph type="title"/>
-          </p:nvPr>
-        </p:nvSpPr>
-        <p:spPr/>
-        <p:txBody>
-          <a:bodyPr/>
-          <a:lstStyle/>
-          <a:p>
-            <a:r>
-              <a:t>Slide 37: agile response framework</a:t>
-            </a:r>
-          </a:p>
-        </p:txBody>
-      </p:sp>
-      <p:sp>
-        <p:nvSpPr>
-          <p:cNvPr id="3" name="Content Placeholder 2"/>
-          <p:cNvSpPr>
-            <a:spLocks noGrp="1"/>
-          </p:cNvSpPr>
-          <p:nvPr>
-            <p:ph idx="1"/>
-          </p:nvPr>
-        </p:nvSpPr>
-        <p:spPr/>
-        <p:txBody>
-          <a:bodyPr/>
-          <a:lstStyle/>
-          <a:p>
-            <a:r>
-              <a:t>Regarding the strategy, we believe that bleeding-edge creative disruption is the key to unlocking market share in SEA. Our team will deploy omni-channel synergy to maximize reach.</a:t>
-            </a:r>
-          </a:p>
-        </p:txBody>
-      </p:sp>
-    </p:spTree>
-  </p:cSld>
-  <p:clrMapOvr>
-    <a:masterClrMapping/>
-  </p:clrMapOvr>
-</p:sld>
-</file>
-
-<file path=ppt/slides/slide39.xml><?xml version="1.0" encoding="utf-8"?>
-<p:sld xmlns:a="http://schemas.openxmlformats.org/drawingml/2006/main" xmlns:p="http://schemas.openxmlformats.org/presentationml/2006/main" xmlns:r="http://schemas.openxmlformats.org/officeDocument/2006/relationships">
-  <p:cSld>
-    <p:spTree>
-      <p:nvGrpSpPr>
-        <p:cNvPr id="1" name=""/>
-        <p:cNvGrpSpPr/>
-        <p:nvPr/>
-      </p:nvGrpSpPr>
-      <p:grpSpPr/>
-      <p:sp>
-        <p:nvSpPr>
-          <p:cNvPr id="2" name="Title 1"/>
-          <p:cNvSpPr>
-            <a:spLocks noGrp="1"/>
-          </p:cNvSpPr>
-          <p:nvPr>
-            <p:ph type="title"/>
-          </p:nvPr>
-        </p:nvSpPr>
-        <p:spPr/>
-        <p:txBody>
-          <a:bodyPr/>
-          <a:lstStyle/>
-          <a:p>
-            <a:r>
-              <a:t>Slide 38: quantum-leap brand awareness</a:t>
-            </a:r>
-          </a:p>
-        </p:txBody>
-      </p:sp>
-      <p:sp>
-        <p:nvSpPr>
-          <p:cNvPr id="3" name="Content Placeholder 2"/>
-          <p:cNvSpPr>
-            <a:spLocks noGrp="1"/>
-          </p:cNvSpPr>
-          <p:nvPr>
-            <p:ph idx="1"/>
-          </p:nvPr>
-        </p:nvSpPr>
-        <p:spPr/>
-        <p:txBody>
-          <a:bodyPr/>
-          <a:lstStyle/>
-          <a:p>
-            <a:r>
-              <a:t>Compliance is at the heart of our 360-degree brand amplification system. We utilize hyper-local cultural relevance to verify all claims against regional regulations.</a:t>
+              <a:t>The technical specifications for the TVC production involve hyper-local cultural relevance across all regional hubs. This allows for a paradigm-shifting ROI that is both cost-effective and high-impact. [COMMERCIAL] The itemized fee for TVC Development is projected at $120,139 inclusive of agency overhead but excluding third-party pass-throughs.</a:t>
+            </a:r>
+          </a:p>
+          <a:p>
+            <a:r>
+              <a:t>Key Metric for TVC Development: 86% confidence interval.</a:t>
             </a:r>
           </a:p>
         </p:txBody>
@@ -5164,7 +3301,7 @@
           <a:lstStyle/>
           <a:p>
             <a:r>
-              <a:t>Slide 3: quantum-leap brand awareness</a:t>
+              <a:t>TVC Production Framework</a:t>
             </a:r>
           </a:p>
         </p:txBody>
@@ -5185,127 +3322,12 @@
           <a:lstStyle/>
           <a:p>
             <a:r>
-              <a:t>Regarding the strategy, we believe that 360-degree brand amplification is the key to unlocking market share in SEA. Our team will deploy agile response framework to maximize reach.</a:t>
-            </a:r>
-          </a:p>
-        </p:txBody>
-      </p:sp>
-    </p:spTree>
-  </p:cSld>
-  <p:clrMapOvr>
-    <a:masterClrMapping/>
-  </p:clrMapOvr>
-</p:sld>
-</file>
-
-<file path=ppt/slides/slide40.xml><?xml version="1.0" encoding="utf-8"?>
-<p:sld xmlns:a="http://schemas.openxmlformats.org/drawingml/2006/main" xmlns:p="http://schemas.openxmlformats.org/presentationml/2006/main" xmlns:r="http://schemas.openxmlformats.org/officeDocument/2006/relationships">
-  <p:cSld>
-    <p:spTree>
-      <p:nvGrpSpPr>
-        <p:cNvPr id="1" name=""/>
-        <p:cNvGrpSpPr/>
-        <p:nvPr/>
-      </p:nvGrpSpPr>
-      <p:grpSpPr/>
-      <p:sp>
-        <p:nvSpPr>
-          <p:cNvPr id="2" name="Title 1"/>
-          <p:cNvSpPr>
-            <a:spLocks noGrp="1"/>
-          </p:cNvSpPr>
-          <p:nvPr>
-            <p:ph type="title"/>
-          </p:nvPr>
-        </p:nvSpPr>
-        <p:spPr/>
-        <p:txBody>
-          <a:bodyPr/>
-          <a:lstStyle/>
-          <a:p>
-            <a:r>
-              <a:t>Slide 39: holistic consumer engagement</a:t>
-            </a:r>
-          </a:p>
-        </p:txBody>
-      </p:sp>
-      <p:sp>
-        <p:nvSpPr>
-          <p:cNvPr id="3" name="Content Placeholder 2"/>
-          <p:cNvSpPr>
-            <a:spLocks noGrp="1"/>
-          </p:cNvSpPr>
-          <p:nvPr>
-            <p:ph idx="1"/>
-          </p:nvPr>
-        </p:nvSpPr>
-        <p:spPr/>
-        <p:txBody>
-          <a:bodyPr/>
-          <a:lstStyle/>
-          <a:p>
-            <a:r>
-              <a:t>The technical specifications for the TVC production involve bleeding-edge creative disruption across all regional hubs. This allows for a holistic consumer engagement that is both cost-effective and high-impact. [METRIC] Our internal audit scores this workstream at a 98% efficiency rating.</a:t>
-            </a:r>
-          </a:p>
-        </p:txBody>
-      </p:sp>
-    </p:spTree>
-  </p:cSld>
-  <p:clrMapOvr>
-    <a:masterClrMapping/>
-  </p:clrMapOvr>
-</p:sld>
-</file>
-
-<file path=ppt/slides/slide41.xml><?xml version="1.0" encoding="utf-8"?>
-<p:sld xmlns:a="http://schemas.openxmlformats.org/drawingml/2006/main" xmlns:p="http://schemas.openxmlformats.org/presentationml/2006/main" xmlns:r="http://schemas.openxmlformats.org/officeDocument/2006/relationships">
-  <p:cSld>
-    <p:spTree>
-      <p:nvGrpSpPr>
-        <p:cNvPr id="1" name=""/>
-        <p:cNvGrpSpPr/>
-        <p:nvPr/>
-      </p:nvGrpSpPr>
-      <p:grpSpPr/>
-      <p:sp>
-        <p:nvSpPr>
-          <p:cNvPr id="2" name="Title 1"/>
-          <p:cNvSpPr>
-            <a:spLocks noGrp="1"/>
-          </p:cNvSpPr>
-          <p:nvPr>
-            <p:ph type="title"/>
-          </p:nvPr>
-        </p:nvSpPr>
-        <p:spPr/>
-        <p:txBody>
-          <a:bodyPr/>
-          <a:lstStyle/>
-          <a:p>
-            <a:r>
-              <a:t>Slide 40: agile response framework</a:t>
-            </a:r>
-          </a:p>
-        </p:txBody>
-      </p:sp>
-      <p:sp>
-        <p:nvSpPr>
-          <p:cNvPr id="3" name="Content Placeholder 2"/>
-          <p:cNvSpPr>
-            <a:spLocks noGrp="1"/>
-          </p:cNvSpPr>
-          <p:nvPr>
-            <p:ph idx="1"/>
-          </p:nvPr>
-        </p:nvSpPr>
-        <p:spPr/>
-        <p:txBody>
-          <a:bodyPr/>
-          <a:lstStyle/>
-          <a:p>
-            <a:r>
-              <a:t>Regarding the strategy, we believe that quantum-leap brand awareness is the key to unlocking market share in SEA. Our team will deploy holistic consumer engagement to maximize reach.</a:t>
+              <a:t>Regarding the strategy, we believe that quantum-leap brand awareness is the key to unlocking market share in SEA. Our team will deploy data-driven market penetration to maximize reach. [COMMERCIAL] The itemized fee for TVC Production is projected at $379,300 inclusive of agency overhead but excluding third-party pass-throughs.</a:t>
+            </a:r>
+          </a:p>
+          <a:p>
+            <a:r>
+              <a:t>Key Metric for TVC Production: 88% confidence interval.</a:t>
             </a:r>
           </a:p>
         </p:txBody>
@@ -5344,7 +3366,7 @@
           <a:lstStyle/>
           <a:p>
             <a:r>
-              <a:t>Slide 4: growth-hacking strategy</a:t>
+              <a:t>Social Organic Framework</a:t>
             </a:r>
           </a:p>
         </p:txBody>
@@ -5365,7 +3387,12 @@
           <a:lstStyle/>
           <a:p>
             <a:r>
-              <a:t>Compliance is at the heart of our holistic consumer engagement system. We utilize bleeding-edge creative disruption to verify all claims against regional regulations.</a:t>
+              <a:t>Our paradigm-shifting ROI approach ensures that the NutriKid launch will exceed all stakeholder expectations. Through careful bleeding-edge creative disruption and rigorous testing, we have developed a methodology that scales effortlessly. [COMMERCIAL] The itemized fee for Social Organic is projected at $128,256 inclusive of agency overhead but excluding third-party pass-throughs.</a:t>
+            </a:r>
+          </a:p>
+          <a:p>
+            <a:r>
+              <a:t>Key Metric for Social Organic: 95% confidence interval.</a:t>
             </a:r>
           </a:p>
         </p:txBody>
@@ -5404,7 +3431,7 @@
           <a:lstStyle/>
           <a:p>
             <a:r>
-              <a:t>Slide 5: paradigm-shifting ROI</a:t>
+              <a:t>Social Paid Framework</a:t>
             </a:r>
           </a:p>
         </p:txBody>
@@ -5425,7 +3452,12 @@
           <a:lstStyle/>
           <a:p>
             <a:r>
-              <a:t>The technical specifications for the TVC production involve agile response framework across all regional hubs. This allows for a omni-channel synergy that is both cost-effective and high-impact.</a:t>
+              <a:t>Our agile response framework approach ensures that the NutriKid launch will exceed all stakeholder expectations. Through careful synergistic touchpoints and rigorous testing, we have developed a methodology that scales effortlessly. [COMMERCIAL] The itemized fee for Social Paid is projected at $146,344 inclusive of agency overhead but excluding third-party pass-throughs.</a:t>
+            </a:r>
+          </a:p>
+          <a:p>
+            <a:r>
+              <a:t>Key Metric for Social Paid: 90% confidence interval.</a:t>
             </a:r>
           </a:p>
         </p:txBody>
@@ -5464,7 +3496,7 @@
           <a:lstStyle/>
           <a:p>
             <a:r>
-              <a:t>Slide 6: holistic consumer engagement</a:t>
+              <a:t>Compliance Review Framework</a:t>
             </a:r>
           </a:p>
         </p:txBody>
@@ -5485,7 +3517,12 @@
           <a:lstStyle/>
           <a:p>
             <a:r>
-              <a:t>Regarding the strategy, we believe that hyper-local cultural relevance is the key to unlocking market share in SEA. Our team will deploy paradigm-shifting ROI to maximize reach. [METRIC] Our internal audit scores this workstream at a 98% efficiency rating.</a:t>
+              <a:t>Our hyper-local cultural relevance approach ensures that the NutriKid launch will exceed all stakeholder expectations. Through careful holistic consumer engagement and rigorous testing, we have developed a methodology that scales effortlessly. [COMMERCIAL] The itemized fee for Compliance Review is projected at $32,019 inclusive of agency overhead but excluding third-party pass-throughs.</a:t>
+            </a:r>
+          </a:p>
+          <a:p>
+            <a:r>
+              <a:t>Key Metric for Compliance Review: 86% confidence interval.</a:t>
             </a:r>
           </a:p>
         </p:txBody>
@@ -5524,7 +3561,7 @@
           <a:lstStyle/>
           <a:p>
             <a:r>
-              <a:t>Slide 7: growth-hacking strategy</a:t>
+              <a:t>Program Management Framework</a:t>
             </a:r>
           </a:p>
         </p:txBody>
@@ -5545,67 +3582,12 @@
           <a:lstStyle/>
           <a:p>
             <a:r>
-              <a:t>The technical specifications for the TVC production involve omni-channel synergy across all regional hubs. This allows for a hyper-local cultural relevance that is both cost-effective and high-impact. [METRIC] Our internal audit scores this workstream at a 85% efficiency rating.</a:t>
-            </a:r>
-          </a:p>
-        </p:txBody>
-      </p:sp>
-    </p:spTree>
-  </p:cSld>
-  <p:clrMapOvr>
-    <a:masterClrMapping/>
-  </p:clrMapOvr>
-</p:sld>
-</file>
-
-<file path=ppt/slides/slide9.xml><?xml version="1.0" encoding="utf-8"?>
-<p:sld xmlns:a="http://schemas.openxmlformats.org/drawingml/2006/main" xmlns:p="http://schemas.openxmlformats.org/presentationml/2006/main" xmlns:r="http://schemas.openxmlformats.org/officeDocument/2006/relationships">
-  <p:cSld>
-    <p:spTree>
-      <p:nvGrpSpPr>
-        <p:cNvPr id="1" name=""/>
-        <p:cNvGrpSpPr/>
-        <p:nvPr/>
-      </p:nvGrpSpPr>
-      <p:grpSpPr/>
-      <p:sp>
-        <p:nvSpPr>
-          <p:cNvPr id="2" name="Title 1"/>
-          <p:cNvSpPr>
-            <a:spLocks noGrp="1"/>
-          </p:cNvSpPr>
-          <p:nvPr>
-            <p:ph type="title"/>
-          </p:nvPr>
-        </p:nvSpPr>
-        <p:spPr/>
-        <p:txBody>
-          <a:bodyPr/>
-          <a:lstStyle/>
-          <a:p>
-            <a:r>
-              <a:t>Slide 8: growth-hacking strategy</a:t>
-            </a:r>
-          </a:p>
-        </p:txBody>
-      </p:sp>
-      <p:sp>
-        <p:nvSpPr>
-          <p:cNvPr id="3" name="Content Placeholder 2"/>
-          <p:cNvSpPr>
-            <a:spLocks noGrp="1"/>
-          </p:cNvSpPr>
-          <p:nvPr>
-            <p:ph idx="1"/>
-          </p:nvPr>
-        </p:nvSpPr>
-        <p:spPr/>
-        <p:txBody>
-          <a:bodyPr/>
-          <a:lstStyle/>
-          <a:p>
-            <a:r>
-              <a:t>The technical specifications for the TVC production involve quantum-leap brand awareness across all regional hubs. This allows for a synergistic touchpoints that is both cost-effective and high-impact.</a:t>
+              <a:t>Our bleeding-edge creative disruption approach ensures that the NutriKid launch will exceed all stakeholder expectations. Through careful data-driven market penetration and rigorous testing, we have developed a methodology that scales effortlessly. [COMMERCIAL] The itemized fee for Program Management is projected at $64,456 inclusive of agency overhead but excluding third-party pass-throughs.</a:t>
+            </a:r>
+          </a:p>
+          <a:p>
+            <a:r>
+              <a:t>Key Metric for Program Management: 94% confidence interval.</a:t>
             </a:r>
           </a:p>
         </p:txBody>

</xml_diff>